<commit_message>
chore(cleanup): 미사용 brand_comparison_sheet.dart 제거
Build 426 에서 Premium compose 진입(_openCompose)이 제거되며 BrandComparisonSheet
트리거가 사라져 완전 미참조 dead 파일이 됨. analyze 클린 확인 후 삭제.

Co-Authored-By: Claude Opus 4.8 <noreply@anthropic.com>
</commit_message>
<xml_diff>
--- a/docs/ir_deck_build/Thiscount_IR_Deck_KO.pptx
+++ b/docs/ir_deck_build/Thiscount_IR_Deck_KO.pptx
@@ -4198,7 +4198,7 @@
               <a:buNone/>
             </a:pPr>
             <a:r>
-              <a:rPr lang="en-US" sz="1050" i="1" dirty="0">
+              <a:rPr lang="en-US" sz="1050" dirty="0">
                 <a:solidFill>
                   <a:srgbClr val="9A9AA5"/>
                 </a:solidFill>
@@ -6016,7 +6016,7 @@
                 <a:ea typeface="Apple SD Gothic Neo" pitchFamily="34" charset="-122"/>
                 <a:cs typeface="Apple SD Gothic Neo" pitchFamily="34" charset="-120"/>
               </a:rPr>
-              <a:t>출시 직전 — 자본은 </a:t>
+              <a:t>출시 직전, 자본은 </a:t>
             </a:r>
             <a:pPr algn="l" indent="0" marL="0">
               <a:buNone/>
@@ -8363,7 +8363,7 @@
               <a:buNone/>
             </a:pPr>
             <a:r>
-              <a:rPr lang="en-US" sz="1500" i="1" dirty="0">
+              <a:rPr lang="en-US" sz="1500" dirty="0">
                 <a:solidFill>
                   <a:srgbClr val="9A9AA5"/>
                 </a:solidFill>
@@ -8377,7 +8377,7 @@
               <a:buNone/>
             </a:pPr>
             <a:r>
-              <a:rPr lang="en-US" sz="1500" b="1" i="1" dirty="0">
+              <a:rPr lang="en-US" sz="1500" b="1" dirty="0">
                 <a:solidFill>
                   <a:srgbClr val="FFD60A"/>
                 </a:solidFill>
@@ -8391,7 +8391,7 @@
               <a:buNone/>
             </a:pPr>
             <a:r>
-              <a:rPr lang="en-US" sz="1500" i="1" dirty="0">
+              <a:rPr lang="en-US" sz="1500" dirty="0">
                 <a:solidFill>
                   <a:srgbClr val="9A9AA5"/>
                 </a:solidFill>
@@ -9174,7 +9174,7 @@
               <a:buNone/>
             </a:pPr>
             <a:r>
-              <a:rPr lang="en-US" sz="1500" i="1" dirty="0">
+              <a:rPr lang="en-US" sz="1500" dirty="0">
                 <a:solidFill>
                   <a:srgbClr val="B8FF5C"/>
                 </a:solidFill>
@@ -9404,8 +9404,8 @@
         </p:nvSpPr>
         <p:spPr>
           <a:xfrm>
-            <a:off x="685800" y="2514600"/>
-            <a:ext cx="3383280" cy="2834640"/>
+            <a:off x="502920" y="2514600"/>
+            <a:ext cx="3291840" cy="2834640"/>
           </a:xfrm>
           <a:prstGeom prst="roundRect">
             <a:avLst>
@@ -9431,7 +9431,7 @@
         </p:nvSpPr>
         <p:spPr>
           <a:xfrm>
-            <a:off x="1965960" y="2103120"/>
+            <a:off x="1737360" y="2103120"/>
             <a:ext cx="822960" cy="822960"/>
           </a:xfrm>
           <a:prstGeom prst="ellipse">
@@ -9451,7 +9451,7 @@
         </p:nvSpPr>
         <p:spPr>
           <a:xfrm>
-            <a:off x="1965960" y="2103120"/>
+            <a:off x="1737360" y="2103120"/>
             <a:ext cx="822960" cy="822960"/>
           </a:xfrm>
           <a:prstGeom prst="rect">
@@ -9498,7 +9498,7 @@
         </p:blipFill>
         <p:spPr>
           <a:xfrm>
-            <a:off x="2011680" y="3154680"/>
+            <a:off x="1783080" y="3154680"/>
             <a:ext cx="731520" cy="731520"/>
           </a:xfrm>
           <a:prstGeom prst="rect">
@@ -9514,8 +9514,8 @@
         </p:nvSpPr>
         <p:spPr>
           <a:xfrm>
-            <a:off x="868680" y="4023360"/>
-            <a:ext cx="3017520" cy="411480"/>
+            <a:off x="685800" y="4023360"/>
+            <a:ext cx="2926080" cy="411480"/>
           </a:xfrm>
           <a:prstGeom prst="rect">
             <a:avLst/>
@@ -9553,8 +9553,8 @@
         </p:nvSpPr>
         <p:spPr>
           <a:xfrm>
-            <a:off x="868680" y="4480560"/>
-            <a:ext cx="3017520" cy="731520"/>
+            <a:off x="685800" y="4480560"/>
+            <a:ext cx="2926080" cy="731520"/>
           </a:xfrm>
           <a:prstGeom prst="rect">
             <a:avLst/>
@@ -9609,8 +9609,8 @@
         </p:nvSpPr>
         <p:spPr>
           <a:xfrm>
-            <a:off x="4114800" y="3337560"/>
-            <a:ext cx="685800" cy="822960"/>
+            <a:off x="3840480" y="3337560"/>
+            <a:ext cx="548640" cy="822960"/>
           </a:xfrm>
           <a:prstGeom prst="rect">
             <a:avLst/>
@@ -9648,8 +9648,8 @@
         </p:nvSpPr>
         <p:spPr>
           <a:xfrm>
-            <a:off x="4846320" y="2514600"/>
-            <a:ext cx="3383280" cy="2834640"/>
+            <a:off x="4434840" y="2514600"/>
+            <a:ext cx="3291840" cy="2834640"/>
           </a:xfrm>
           <a:prstGeom prst="roundRect">
             <a:avLst>
@@ -9675,7 +9675,7 @@
         </p:nvSpPr>
         <p:spPr>
           <a:xfrm>
-            <a:off x="6126480" y="2103120"/>
+            <a:off x="5669280" y="2103120"/>
             <a:ext cx="822960" cy="822960"/>
           </a:xfrm>
           <a:prstGeom prst="ellipse">
@@ -9695,7 +9695,7 @@
         </p:nvSpPr>
         <p:spPr>
           <a:xfrm>
-            <a:off x="6126480" y="2103120"/>
+            <a:off x="5669280" y="2103120"/>
             <a:ext cx="822960" cy="822960"/>
           </a:xfrm>
           <a:prstGeom prst="rect">
@@ -9742,7 +9742,7 @@
         </p:blipFill>
         <p:spPr>
           <a:xfrm>
-            <a:off x="6172200" y="3154680"/>
+            <a:off x="5715000" y="3154680"/>
             <a:ext cx="731520" cy="731520"/>
           </a:xfrm>
           <a:prstGeom prst="rect">
@@ -9758,8 +9758,8 @@
         </p:nvSpPr>
         <p:spPr>
           <a:xfrm>
-            <a:off x="5029200" y="4023360"/>
-            <a:ext cx="3017520" cy="411480"/>
+            <a:off x="4617720" y="4023360"/>
+            <a:ext cx="2926080" cy="411480"/>
           </a:xfrm>
           <a:prstGeom prst="rect">
             <a:avLst/>
@@ -9797,8 +9797,8 @@
         </p:nvSpPr>
         <p:spPr>
           <a:xfrm>
-            <a:off x="5029200" y="4480560"/>
-            <a:ext cx="3017520" cy="731520"/>
+            <a:off x="4617720" y="4480560"/>
+            <a:ext cx="2926080" cy="731520"/>
           </a:xfrm>
           <a:prstGeom prst="rect">
             <a:avLst/>
@@ -9853,8 +9853,8 @@
         </p:nvSpPr>
         <p:spPr>
           <a:xfrm>
-            <a:off x="8275320" y="3337560"/>
-            <a:ext cx="685800" cy="822960"/>
+            <a:off x="7772400" y="3337560"/>
+            <a:ext cx="548640" cy="822960"/>
           </a:xfrm>
           <a:prstGeom prst="rect">
             <a:avLst/>
@@ -9892,8 +9892,8 @@
         </p:nvSpPr>
         <p:spPr>
           <a:xfrm>
-            <a:off x="9006840" y="2514600"/>
-            <a:ext cx="3383280" cy="2834640"/>
+            <a:off x="8366760" y="2514600"/>
+            <a:ext cx="3291840" cy="2834640"/>
           </a:xfrm>
           <a:prstGeom prst="roundRect">
             <a:avLst>
@@ -9919,7 +9919,7 @@
         </p:nvSpPr>
         <p:spPr>
           <a:xfrm>
-            <a:off x="10287000" y="2103120"/>
+            <a:off x="9601200" y="2103120"/>
             <a:ext cx="822960" cy="822960"/>
           </a:xfrm>
           <a:prstGeom prst="ellipse">
@@ -9939,7 +9939,7 @@
         </p:nvSpPr>
         <p:spPr>
           <a:xfrm>
-            <a:off x="10287000" y="2103120"/>
+            <a:off x="9601200" y="2103120"/>
             <a:ext cx="822960" cy="822960"/>
           </a:xfrm>
           <a:prstGeom prst="rect">
@@ -9986,7 +9986,7 @@
         </p:blipFill>
         <p:spPr>
           <a:xfrm>
-            <a:off x="10332720" y="3154680"/>
+            <a:off x="9646920" y="3154680"/>
             <a:ext cx="731520" cy="731520"/>
           </a:xfrm>
           <a:prstGeom prst="rect">
@@ -10002,8 +10002,8 @@
         </p:nvSpPr>
         <p:spPr>
           <a:xfrm>
-            <a:off x="9189720" y="4023360"/>
-            <a:ext cx="3017520" cy="411480"/>
+            <a:off x="8549640" y="4023360"/>
+            <a:ext cx="2926080" cy="411480"/>
           </a:xfrm>
           <a:prstGeom prst="rect">
             <a:avLst/>
@@ -10041,8 +10041,8 @@
         </p:nvSpPr>
         <p:spPr>
           <a:xfrm>
-            <a:off x="9189720" y="4480560"/>
-            <a:ext cx="3017520" cy="731520"/>
+            <a:off x="8549640" y="4480560"/>
+            <a:ext cx="2926080" cy="731520"/>
           </a:xfrm>
           <a:prstGeom prst="rect">
             <a:avLst/>
@@ -10114,7 +10114,7 @@
               <a:buNone/>
             </a:pPr>
             <a:r>
-              <a:rPr lang="en-US" sz="1500" i="1" dirty="0">
+              <a:rPr lang="en-US" sz="1500" dirty="0">
                 <a:solidFill>
                   <a:srgbClr val="9A9AA5"/>
                 </a:solidFill>
@@ -11784,7 +11784,7 @@
               <a:buNone/>
             </a:pPr>
             <a:r>
-              <a:rPr lang="en-US" sz="1400" i="1" dirty="0">
+              <a:rPr lang="en-US" sz="1400" dirty="0">
                 <a:solidFill>
                   <a:srgbClr val="9A9AA5"/>
                 </a:solidFill>
@@ -11798,7 +11798,7 @@
               <a:buNone/>
             </a:pPr>
             <a:r>
-              <a:rPr lang="en-US" sz="1400" b="1" i="1" dirty="0">
+              <a:rPr lang="en-US" sz="1400" b="1" dirty="0">
                 <a:solidFill>
                   <a:srgbClr val="B8FF5C"/>
                 </a:solidFill>
@@ -12694,7 +12694,7 @@
               <a:buNone/>
             </a:pPr>
             <a:r>
-              <a:rPr lang="en-US" sz="1100" i="1" dirty="0">
+              <a:rPr lang="en-US" sz="1100" dirty="0">
                 <a:solidFill>
                   <a:srgbClr val="9A9AA5"/>
                 </a:solidFill>
@@ -12910,7 +12910,7 @@
                 <a:ea typeface="Apple SD Gothic Neo" pitchFamily="34" charset="-122"/>
                 <a:cs typeface="Apple SD Gothic Neo" pitchFamily="34" charset="-120"/>
               </a:rPr>
-              <a:t>양면 수익 — </a:t>
+              <a:t>양면 수익 : </a:t>
             </a:r>
             <a:pPr algn="l" indent="0" marL="0">
               <a:buNone/>
@@ -13555,7 +13555,7 @@
               <a:buNone/>
             </a:pPr>
             <a:r>
-              <a:rPr lang="en-US" sz="1300" i="1" dirty="0">
+              <a:rPr lang="en-US" sz="1300" dirty="0">
                 <a:solidFill>
                   <a:srgbClr val="FFD60A"/>
                 </a:solidFill>

</xml_diff>